<commit_message>
Slides: Find and Replace, effects by paragraph in the show, notes pages and handouts in the PDF
find.h (Edit > Find and Replace, Ctrl+F: every slide's text and tables, the case or not,
Replace / Replace All in one Undo); show.h: a text animated by paragraph shows its
paragraphs one after the other (each on a click, or after the one before), through a
clip down to the paragraph playing; Export as PDF asks for the slides, notes pages (A4:
the slide and its notes) or handouts (2, 3 with lines for notes, 6 a page), the text
embedded. The sample's terrace list now enters by paragraph. Tested (41 checks); docs.

Co-Authored-By: Claude Opus 5.5 <noreply@anthropic.com>
Claude-Session: https://claude.ai/code/session_01KMcgDWwGfFCT3sthF2B4dY
</commit_message>
<xml_diff>
--- a/sdcard/docs/cafe-2026.pptx
+++ b/sdcard/docs/cafe-2026.pptx
@@ -5171,7 +5171,11 @@
                                           </p:stCondLst>
                                         </p:cTn>
                                         <p:tgtEl>
-                                          <p:spTgt spid="4"/>
+                                          <p:spTgt spid="4">
+                                            <p:txEl>
+                                              <p:pRg st="0" end="0"/>
+                                            </p:txEl>
+                                          </p:spTgt>
                                         </p:tgtEl>
                                         <p:attrNameLst>
                                           <p:attrName>style.visibility</p:attrName>
@@ -5185,7 +5189,11 @@
                                       <p:cBhvr>
                                         <p:cTn id="7" dur="600"/>
                                         <p:tgtEl>
-                                          <p:spTgt spid="4"/>
+                                          <p:spTgt spid="4">
+                                            <p:txEl>
+                                              <p:pRg st="0" end="0"/>
+                                            </p:txEl>
+                                          </p:spTgt>
                                         </p:tgtEl>
                                       </p:cBhvr>
                                     </p:animEffect>
@@ -5193,7 +5201,275 @@
                                       <p:cBhvr additive="base">
                                         <p:cTn id="8" dur="600" fill="hold"/>
                                         <p:tgtEl>
-                                          <p:spTgt spid="4"/>
+                                          <p:spTgt spid="4">
+                                            <p:txEl>
+                                              <p:pRg st="0" end="0"/>
+                                            </p:txEl>
+                                          </p:spTgt>
+                                        </p:tgtEl>
+                                        <p:attrNameLst>
+                                          <p:attrName>ppt_y</p:attrName>
+                                        </p:attrNameLst>
+                                      </p:cBhvr>
+                                      <p:tavLst>
+                                        <p:tav tm="0">
+                                          <p:val>
+                                            <p:strVal val="#ppt_y+0.1"/>
+                                          </p:val>
+                                        </p:tav>
+                                        <p:tav tm="100000">
+                                          <p:val>
+                                            <p:strVal val="#ppt_y"/>
+                                          </p:val>
+                                        </p:tav>
+                                      </p:tavLst>
+                                    </p:anim>
+                                  </p:childTnLst>
+                                </p:cTn>
+                              </p:par>
+                            </p:childTnLst>
+                          </p:cTn>
+                        </p:par>
+                      </p:childTnLst>
+                    </p:cTn>
+                  </p:par>
+                  <p:par>
+                    <p:cTn id="9" fill="hold">
+                      <p:stCondLst>
+                        <p:cond delay="indefinite"/>
+                      </p:stCondLst>
+                      <p:childTnLst>
+                        <p:par>
+                          <p:cTn id="10" fill="hold">
+                            <p:stCondLst>
+                              <p:cond delay="0"/>
+                            </p:stCondLst>
+                            <p:childTnLst>
+                              <p:par>
+                                <p:cTn id="11" presetID="42" presetClass="entr" presetSubtype="4" fill="hold" grpId="0" nodeType="clickEffect">
+                                  <p:stCondLst>
+                                    <p:cond delay="0"/>
+                                  </p:stCondLst>
+                                  <p:childTnLst>
+                                    <p:set>
+                                      <p:cBhvr>
+                                        <p:cTn id="12" dur="1" fill="hold">
+                                          <p:stCondLst>
+                                            <p:cond delay="0"/>
+                                          </p:stCondLst>
+                                        </p:cTn>
+                                        <p:tgtEl>
+                                          <p:spTgt spid="4">
+                                            <p:txEl>
+                                              <p:pRg st="1" end="1"/>
+                                            </p:txEl>
+                                          </p:spTgt>
+                                        </p:tgtEl>
+                                        <p:attrNameLst>
+                                          <p:attrName>style.visibility</p:attrName>
+                                        </p:attrNameLst>
+                                      </p:cBhvr>
+                                      <p:to>
+                                        <p:strVal val="visible"/>
+                                      </p:to>
+                                    </p:set>
+                                    <p:animEffect transition="in" filter="fade">
+                                      <p:cBhvr>
+                                        <p:cTn id="13" dur="600"/>
+                                        <p:tgtEl>
+                                          <p:spTgt spid="4">
+                                            <p:txEl>
+                                              <p:pRg st="1" end="1"/>
+                                            </p:txEl>
+                                          </p:spTgt>
+                                        </p:tgtEl>
+                                      </p:cBhvr>
+                                    </p:animEffect>
+                                    <p:anim calcmode="lin" valueType="num">
+                                      <p:cBhvr additive="base">
+                                        <p:cTn id="14" dur="600" fill="hold"/>
+                                        <p:tgtEl>
+                                          <p:spTgt spid="4">
+                                            <p:txEl>
+                                              <p:pRg st="1" end="1"/>
+                                            </p:txEl>
+                                          </p:spTgt>
+                                        </p:tgtEl>
+                                        <p:attrNameLst>
+                                          <p:attrName>ppt_y</p:attrName>
+                                        </p:attrNameLst>
+                                      </p:cBhvr>
+                                      <p:tavLst>
+                                        <p:tav tm="0">
+                                          <p:val>
+                                            <p:strVal val="#ppt_y+0.1"/>
+                                          </p:val>
+                                        </p:tav>
+                                        <p:tav tm="100000">
+                                          <p:val>
+                                            <p:strVal val="#ppt_y"/>
+                                          </p:val>
+                                        </p:tav>
+                                      </p:tavLst>
+                                    </p:anim>
+                                  </p:childTnLst>
+                                </p:cTn>
+                              </p:par>
+                            </p:childTnLst>
+                          </p:cTn>
+                        </p:par>
+                      </p:childTnLst>
+                    </p:cTn>
+                  </p:par>
+                  <p:par>
+                    <p:cTn id="15" fill="hold">
+                      <p:stCondLst>
+                        <p:cond delay="indefinite"/>
+                      </p:stCondLst>
+                      <p:childTnLst>
+                        <p:par>
+                          <p:cTn id="16" fill="hold">
+                            <p:stCondLst>
+                              <p:cond delay="0"/>
+                            </p:stCondLst>
+                            <p:childTnLst>
+                              <p:par>
+                                <p:cTn id="17" presetID="42" presetClass="entr" presetSubtype="4" fill="hold" grpId="0" nodeType="clickEffect">
+                                  <p:stCondLst>
+                                    <p:cond delay="0"/>
+                                  </p:stCondLst>
+                                  <p:childTnLst>
+                                    <p:set>
+                                      <p:cBhvr>
+                                        <p:cTn id="18" dur="1" fill="hold">
+                                          <p:stCondLst>
+                                            <p:cond delay="0"/>
+                                          </p:stCondLst>
+                                        </p:cTn>
+                                        <p:tgtEl>
+                                          <p:spTgt spid="4">
+                                            <p:txEl>
+                                              <p:pRg st="2" end="2"/>
+                                            </p:txEl>
+                                          </p:spTgt>
+                                        </p:tgtEl>
+                                        <p:attrNameLst>
+                                          <p:attrName>style.visibility</p:attrName>
+                                        </p:attrNameLst>
+                                      </p:cBhvr>
+                                      <p:to>
+                                        <p:strVal val="visible"/>
+                                      </p:to>
+                                    </p:set>
+                                    <p:animEffect transition="in" filter="fade">
+                                      <p:cBhvr>
+                                        <p:cTn id="19" dur="600"/>
+                                        <p:tgtEl>
+                                          <p:spTgt spid="4">
+                                            <p:txEl>
+                                              <p:pRg st="2" end="2"/>
+                                            </p:txEl>
+                                          </p:spTgt>
+                                        </p:tgtEl>
+                                      </p:cBhvr>
+                                    </p:animEffect>
+                                    <p:anim calcmode="lin" valueType="num">
+                                      <p:cBhvr additive="base">
+                                        <p:cTn id="20" dur="600" fill="hold"/>
+                                        <p:tgtEl>
+                                          <p:spTgt spid="4">
+                                            <p:txEl>
+                                              <p:pRg st="2" end="2"/>
+                                            </p:txEl>
+                                          </p:spTgt>
+                                        </p:tgtEl>
+                                        <p:attrNameLst>
+                                          <p:attrName>ppt_y</p:attrName>
+                                        </p:attrNameLst>
+                                      </p:cBhvr>
+                                      <p:tavLst>
+                                        <p:tav tm="0">
+                                          <p:val>
+                                            <p:strVal val="#ppt_y+0.1"/>
+                                          </p:val>
+                                        </p:tav>
+                                        <p:tav tm="100000">
+                                          <p:val>
+                                            <p:strVal val="#ppt_y"/>
+                                          </p:val>
+                                        </p:tav>
+                                      </p:tavLst>
+                                    </p:anim>
+                                  </p:childTnLst>
+                                </p:cTn>
+                              </p:par>
+                            </p:childTnLst>
+                          </p:cTn>
+                        </p:par>
+                      </p:childTnLst>
+                    </p:cTn>
+                  </p:par>
+                  <p:par>
+                    <p:cTn id="21" fill="hold">
+                      <p:stCondLst>
+                        <p:cond delay="indefinite"/>
+                      </p:stCondLst>
+                      <p:childTnLst>
+                        <p:par>
+                          <p:cTn id="22" fill="hold">
+                            <p:stCondLst>
+                              <p:cond delay="0"/>
+                            </p:stCondLst>
+                            <p:childTnLst>
+                              <p:par>
+                                <p:cTn id="23" presetID="42" presetClass="entr" presetSubtype="4" fill="hold" grpId="0" nodeType="clickEffect">
+                                  <p:stCondLst>
+                                    <p:cond delay="0"/>
+                                  </p:stCondLst>
+                                  <p:childTnLst>
+                                    <p:set>
+                                      <p:cBhvr>
+                                        <p:cTn id="24" dur="1" fill="hold">
+                                          <p:stCondLst>
+                                            <p:cond delay="0"/>
+                                          </p:stCondLst>
+                                        </p:cTn>
+                                        <p:tgtEl>
+                                          <p:spTgt spid="4">
+                                            <p:txEl>
+                                              <p:pRg st="3" end="3"/>
+                                            </p:txEl>
+                                          </p:spTgt>
+                                        </p:tgtEl>
+                                        <p:attrNameLst>
+                                          <p:attrName>style.visibility</p:attrName>
+                                        </p:attrNameLst>
+                                      </p:cBhvr>
+                                      <p:to>
+                                        <p:strVal val="visible"/>
+                                      </p:to>
+                                    </p:set>
+                                    <p:animEffect transition="in" filter="fade">
+                                      <p:cBhvr>
+                                        <p:cTn id="25" dur="600"/>
+                                        <p:tgtEl>
+                                          <p:spTgt spid="4">
+                                            <p:txEl>
+                                              <p:pRg st="3" end="3"/>
+                                            </p:txEl>
+                                          </p:spTgt>
+                                        </p:tgtEl>
+                                      </p:cBhvr>
+                                    </p:animEffect>
+                                    <p:anim calcmode="lin" valueType="num">
+                                      <p:cBhvr additive="base">
+                                        <p:cTn id="26" dur="600" fill="hold"/>
+                                        <p:tgtEl>
+                                          <p:spTgt spid="4">
+                                            <p:txEl>
+                                              <p:pRg st="3" end="3"/>
+                                            </p:txEl>
+                                          </p:spTgt>
                                         </p:tgtEl>
                                         <p:attrNameLst>
                                           <p:attrName>ppt_y</p:attrName>
@@ -5243,7 +5519,7 @@
       </p:par>
     </p:tnLst>
     <p:bldLst>
-      <p:bldP spid="4" grpId="0" animBg="1"/>
+      <p:bldP spid="4" grpId="0" build="p"/>
     </p:bldLst>
   </p:timing>
 </p:sld>

</xml_diff>